<commit_message>
Replace SIH template footer with Honeywell hackathon footer
The deck was filled from the Smart India Hackathon idea template, whose footer
read '@SIH Idea submission- Template' on every slide. Replaced on all slides
with 'Honeywell Hackathon | Problem 3A - Autonomous Production Choke Controller'.
Regenerated deck PDF and the combined submission PDF. Verified: 0 SIH references
remain.
</commit_message>
<xml_diff>
--- a/IDEA_Presentation_Format.pptx
+++ b/IDEA_Presentation_Format.pptx
@@ -5620,7 +5620,7 @@
             </a:pPr>
             <a:r>
               <a:rPr lang="en-US"/>
-              <a:t>@SIH Idea submission- Template</a:t>
+              <a:t>Honeywell Hackathon  |  Problem 3A - Autonomous Production Choke Controller</a:t>
             </a:r>
           </a:p>
         </p:txBody>
@@ -6273,7 +6273,7 @@
                   <a:schemeClr val="bg1"/>
                 </a:solidFill>
               </a:rPr>
-              <a:t>@SIH Idea submission- Template</a:t>
+              <a:t>Honeywell Hackathon  |  Problem 3A - Autonomous Production Choke Controller</a:t>
             </a:r>
             <a:endParaRPr lang="en-US" dirty="0">
               <a:solidFill>
@@ -6579,7 +6579,7 @@
                   <a:schemeClr val="bg1"/>
                 </a:solidFill>
               </a:rPr>
-              <a:t>@SIH Idea submission- Template</a:t>
+              <a:t>Honeywell Hackathon  |  Problem 3A - Autonomous Production Choke Controller</a:t>
             </a:r>
             <a:endParaRPr lang="en-US" dirty="0">
               <a:solidFill>
@@ -6927,7 +6927,7 @@
                 <a:ea typeface="+mn-ea"/>
                 <a:cs typeface="+mn-cs"/>
               </a:rPr>
-              <a:t>@SIH Idea submission- Template</a:t>
+              <a:t>Honeywell Hackathon  |  Problem 3A - Autonomous Production Choke Controller</a:t>
             </a:r>
             <a:endParaRPr kumimoji="0" lang="en-US" sz="1200" b="0" i="0" u="none" strike="noStrike" kern="1200" cap="none" spc="0" normalizeH="0" baseline="0" noProof="0" dirty="0">
               <a:ln>
@@ -7319,7 +7319,7 @@
                 <a:ea typeface="+mn-ea"/>
                 <a:cs typeface="+mn-cs"/>
               </a:rPr>
-              <a:t>@SIH Idea submission- Template</a:t>
+              <a:t>Honeywell Hackathon  |  Problem 3A - Autonomous Production Choke Controller</a:t>
             </a:r>
             <a:endParaRPr kumimoji="0" lang="en-US" sz="1200" b="0" i="0" u="none" strike="noStrike" kern="1200" cap="none" spc="0" normalizeH="0" baseline="0" noProof="0" dirty="0">
               <a:ln>
@@ -7885,7 +7885,7 @@
                 <a:ea typeface="+mn-ea"/>
                 <a:cs typeface="+mn-cs"/>
               </a:rPr>
-              <a:t>@SIH Idea submission- Template</a:t>
+              <a:t>Honeywell Hackathon  |  Problem 3A - Autonomous Production Choke Controller</a:t>
             </a:r>
             <a:endParaRPr kumimoji="0" lang="en-US" sz="1200" b="0" i="0" u="none" strike="noStrike" kern="1200" cap="none" spc="0" normalizeH="0" baseline="0" noProof="0" dirty="0">
               <a:ln>

</xml_diff>

<commit_message>
Sharpen headline (0 vs 168, 'knows when to say no'); add robustness section
README leads with the Scenario C result and documents the dashboard and
robustness commands. report.md gains section 8 (robustness, honest numbers,
margin-as-a-dial finding). Deck: robustness line on the safety slide,
dashboard + robustness on the artifacts slide. Both submission PDFs rebuilt
with Figures 7-8 (robustness margins, disturbance recovery); full PDF now
also embeds robustness.py and app.py.
</commit_message>
<xml_diff>
--- a/IDEA_Presentation_Format.pptx
+++ b/IDEA_Presentation_Format.pptx
@@ -7077,11 +7077,11 @@
           <a:p>
             <a:pPr>
               <a:spcAft>
-                <a:spcPts val="500"/>
+                <a:spcPts val="400"/>
               </a:spcAft>
             </a:pPr>
             <a:r>
-              <a:rPr sz="1300" b="1">
+              <a:rPr sz="1250" b="1">
                 <a:solidFill>
                   <a:srgbClr val="222A35"/>
                 </a:solidFill>
@@ -7093,11 +7093,11 @@
           <a:p>
             <a:pPr lvl="1">
               <a:spcAft>
-                <a:spcPts val="500"/>
+                <a:spcPts val="400"/>
               </a:spcAft>
             </a:pPr>
             <a:r>
-              <a:rPr sz="1300" b="0">
+              <a:rPr sz="1250" b="0">
                 <a:solidFill>
                   <a:srgbClr val="555F6B"/>
                 </a:solidFill>
@@ -7109,65 +7109,97 @@
           <a:p>
             <a:pPr>
               <a:spcAft>
-                <a:spcPts val="500"/>
+                <a:spcPts val="400"/>
               </a:spcAft>
             </a:pPr>
             <a:r>
-              <a:rPr sz="1300" b="1">
-                <a:solidFill>
-                  <a:srgbClr val="1E4066"/>
+              <a:rPr sz="1250" b="1">
+                <a:solidFill>
+                  <a:srgbClr val="2E7D32"/>
                 </a:solidFill>
                 <a:latin typeface="Calibri"/>
               </a:rPr>
-              <a:t>Lessons learned:</a:t>
+              <a:t>Robust: 0 violations under +/-20% plant mismatch, unmeasured</a:t>
             </a:r>
           </a:p>
           <a:p>
             <a:pPr lvl="1">
               <a:spcAft>
-                <a:spcPts val="500"/>
+                <a:spcPts val="400"/>
               </a:spcAft>
             </a:pPr>
             <a:r>
-              <a:rPr sz="1300" b="0">
-                <a:solidFill>
-                  <a:srgbClr val="222A35"/>
+              <a:rPr sz="1250" b="1">
+                <a:solidFill>
+                  <a:srgbClr val="2E7D32"/>
                 </a:solidFill>
                 <a:latin typeface="Calibri"/>
               </a:rPr>
-              <a:t>Binding constraint is a lower pressure bound, not an upper rate cap</a:t>
+              <a:t>disturbances and 2x noise (22-case stress study, robustness.py)</a:t>
+            </a:r>
+          </a:p>
+          <a:p>
+            <a:pPr>
+              <a:spcAft>
+                <a:spcPts val="400"/>
+              </a:spcAft>
+            </a:pPr>
+            <a:r>
+              <a:rPr sz="1250" b="1">
+                <a:solidFill>
+                  <a:srgbClr val="1E4066"/>
+                </a:solidFill>
+                <a:latin typeface="Calibri"/>
+              </a:rPr>
+              <a:t>Lessons learned:</a:t>
             </a:r>
           </a:p>
           <a:p>
             <a:pPr lvl="1">
               <a:spcAft>
-                <a:spcPts val="500"/>
+                <a:spcPts val="400"/>
               </a:spcAft>
             </a:pPr>
             <a:r>
-              <a:rPr sz="1300" b="0">
+              <a:rPr sz="1250" b="0">
                 <a:solidFill>
                   <a:srgbClr val="222A35"/>
                 </a:solidFill>
                 <a:latin typeface="Calibri"/>
               </a:rPr>
-              <a:t>Monotonicity makes a cheap brute-force MPC provably safe</a:t>
+              <a:t>Binding constraint is a lower pressure bound, not an upper rate cap</a:t>
             </a:r>
           </a:p>
           <a:p>
             <a:pPr lvl="1">
               <a:spcAft>
-                <a:spcPts val="500"/>
+                <a:spcPts val="400"/>
               </a:spcAft>
             </a:pPr>
             <a:r>
-              <a:rPr sz="1300" b="0">
+              <a:rPr sz="1250" b="0">
                 <a:solidFill>
                   <a:srgbClr val="222A35"/>
                 </a:solidFill>
                 <a:latin typeface="Calibri"/>
               </a:rPr>
-              <a:t>Safety margin trades ~4 bbl/hr for zero measured violations</a:t>
+              <a:t>Monotonicity makes a cheap brute-force MPC provably safe</a:t>
+            </a:r>
+          </a:p>
+          <a:p>
+            <a:pPr lvl="1">
+              <a:spcAft>
+                <a:spcPts val="400"/>
+              </a:spcAft>
+            </a:pPr>
+            <a:r>
+              <a:rPr sz="1250" b="0">
+                <a:solidFill>
+                  <a:srgbClr val="222A35"/>
+                </a:solidFill>
+                <a:latin typeface="Calibri"/>
+              </a:rPr>
+              <a:t>Model error costs production, never safety - margin is the dial</a:t>
             </a:r>
           </a:p>
         </p:txBody>
@@ -7634,6 +7666,70 @@
                 <a:latin typeface="Calibri"/>
               </a:rPr>
               <a:t>Executed Jupyter notebook + technical report.md + results/ (plots, metrics.json)</a:t>
+            </a:r>
+          </a:p>
+          <a:p>
+            <a:pPr>
+              <a:spcAft>
+                <a:spcPts val="500"/>
+              </a:spcAft>
+            </a:pPr>
+            <a:r>
+              <a:rPr sz="1300" b="1">
+                <a:solidFill>
+                  <a:srgbClr val="2E7D32"/>
+                </a:solidFill>
+                <a:latin typeface="Calibri"/>
+              </a:rPr>
+              <a:t>Live dashboard:  streamlit run app.py  (scenario presets, per-step</a:t>
+            </a:r>
+          </a:p>
+          <a:p>
+            <a:pPr lvl="1">
+              <a:spcAft>
+                <a:spcPts val="500"/>
+              </a:spcAft>
+            </a:pPr>
+            <a:r>
+              <a:rPr sz="1300" b="0">
+                <a:solidFill>
+                  <a:srgbClr val="555F6B"/>
+                </a:solidFill>
+                <a:latin typeface="Calibri"/>
+              </a:rPr>
+              <a:t>MPC diagnostics: candidates rejected as unsafe, WHP margin)</a:t>
+            </a:r>
+          </a:p>
+          <a:p>
+            <a:pPr>
+              <a:spcAft>
+                <a:spcPts val="500"/>
+              </a:spcAft>
+            </a:pPr>
+            <a:r>
+              <a:rPr sz="1300" b="1">
+                <a:solidFill>
+                  <a:srgbClr val="2E7D32"/>
+                </a:solidFill>
+                <a:latin typeface="Calibri"/>
+              </a:rPr>
+              <a:t>Robustness:  python robustness.py  (22 stress cases: noise, +/-20%</a:t>
+            </a:r>
+          </a:p>
+          <a:p>
+            <a:pPr lvl="1">
+              <a:spcAft>
+                <a:spcPts val="500"/>
+              </a:spcAft>
+            </a:pPr>
+            <a:r>
+              <a:rPr sz="1300" b="0">
+                <a:solidFill>
+                  <a:srgbClr val="555F6B"/>
+                </a:solidFill>
+                <a:latin typeface="Calibri"/>
+              </a:rPr>
+              <a:t>mismatch, unmeasured disturbances)</a:t>
             </a:r>
           </a:p>
           <a:p>

</xml_diff>

<commit_message>
Add clickable GitHub link page + explicit Model assumptions on deck
- Full submission PDF now includes a dedicated 'Repository - browse & run
  live' page with a genuine clickable link annotation (verified) to the repo,
  plus run commands; source stays embedded in Appendix B.
- Deck slide 2 gains an explicit 'Model assumptions' bullet (first-order +
  linear; single naturally flowing well, no gas lift/ESP, constant reservoir
  & GOR; documented envelope), ticking every listed presentation sub-section.
</commit_message>
<xml_diff>
--- a/IDEA_Presentation_Format.pptx
+++ b/IDEA_Presentation_Format.pptx
@@ -6085,11 +6085,11 @@
           <a:p>
             <a:pPr>
               <a:spcAft>
-                <a:spcPts val="600"/>
+                <a:spcPts val="500"/>
               </a:spcAft>
             </a:pPr>
             <a:r>
-              <a:rPr sz="1350" b="1">
+              <a:rPr sz="1250" b="1">
                 <a:solidFill>
                   <a:srgbClr val="222A35"/>
                 </a:solidFill>
@@ -6101,11 +6101,11 @@
           <a:p>
             <a:pPr>
               <a:spcAft>
-                <a:spcPts val="600"/>
+                <a:spcPts val="500"/>
               </a:spcAft>
             </a:pPr>
             <a:r>
-              <a:rPr sz="1350" b="0">
+              <a:rPr sz="1250" b="0">
                 <a:solidFill>
                   <a:srgbClr val="222A35"/>
                 </a:solidFill>
@@ -6117,11 +6117,11 @@
           <a:p>
             <a:pPr>
               <a:spcAft>
-                <a:spcPts val="600"/>
+                <a:spcPts val="500"/>
               </a:spcAft>
             </a:pPr>
             <a:r>
-              <a:rPr sz="1350" b="0">
+              <a:rPr sz="1250" b="0">
                 <a:solidFill>
                   <a:srgbClr val="222A35"/>
                 </a:solidFill>
@@ -6133,11 +6133,11 @@
           <a:p>
             <a:pPr lvl="1">
               <a:spcAft>
-                <a:spcPts val="600"/>
+                <a:spcPts val="500"/>
               </a:spcAft>
             </a:pPr>
             <a:r>
-              <a:rPr sz="1350" b="1">
+              <a:rPr sz="1250" b="1">
                 <a:solidFill>
                   <a:srgbClr val="C0392B"/>
                 </a:solidFill>
@@ -6149,59 +6149,91 @@
           <a:p>
             <a:pPr>
               <a:spcAft>
-                <a:spcPts val="600"/>
+                <a:spcPts val="500"/>
               </a:spcAft>
             </a:pPr>
             <a:r>
-              <a:rPr sz="1350" b="1">
+              <a:rPr sz="1250" b="1">
                 <a:solidFill>
                   <a:srgbClr val="222A35"/>
                 </a:solidFill>
                 <a:latin typeface="Calibri"/>
               </a:rPr>
-              <a:t>Model: ARX(1) per output by least squares</a:t>
+              <a:t>Model assumptions: first-order + linear; single naturally flowing well</a:t>
             </a:r>
           </a:p>
           <a:p>
             <a:pPr lvl="1">
               <a:spcAft>
-                <a:spcPts val="600"/>
+                <a:spcPts val="500"/>
               </a:spcAft>
             </a:pPr>
             <a:r>
-              <a:rPr sz="1350" b="0">
+              <a:rPr sz="1250" b="0">
                 <a:solidFill>
                   <a:srgbClr val="555F6B"/>
                 </a:solidFill>
                 <a:latin typeface="Calibri"/>
               </a:rPr>
-              <a:t>y[k+1] = a.y[k] + (1-a)(b0 + b1.u[k]);  free-run fit 1.5-2.4 % of span</a:t>
+              <a:t>(no gas lift/ESP, constant reservoir &amp; GOR); envelope limits documented</a:t>
             </a:r>
           </a:p>
           <a:p>
             <a:pPr>
               <a:spcAft>
-                <a:spcPts val="600"/>
+                <a:spcPts val="500"/>
               </a:spcAft>
             </a:pPr>
             <a:r>
-              <a:rPr sz="1350" b="1">
+              <a:rPr sz="1250" b="1">
                 <a:solidFill>
                   <a:srgbClr val="222A35"/>
                 </a:solidFill>
                 <a:latin typeface="Calibri"/>
               </a:rPr>
-              <a:t>Identified steady-state gains (per % choke):</a:t>
+              <a:t>Model: ARX(1) per output by least squares</a:t>
             </a:r>
           </a:p>
           <a:p>
             <a:pPr lvl="1">
               <a:spcAft>
-                <a:spcPts val="600"/>
+                <a:spcPts val="500"/>
               </a:spcAft>
             </a:pPr>
             <a:r>
-              <a:rPr sz="1350" b="0">
+              <a:rPr sz="1250" b="0">
+                <a:solidFill>
+                  <a:srgbClr val="555F6B"/>
+                </a:solidFill>
+                <a:latin typeface="Calibri"/>
+              </a:rPr>
+              <a:t>y[k+1] = a.y[k] + (1-a)(b0 + b1.u[k]);  free-run fit 1.5-2.4 % of span</a:t>
+            </a:r>
+          </a:p>
+          <a:p>
+            <a:pPr>
+              <a:spcAft>
+                <a:spcPts val="500"/>
+              </a:spcAft>
+            </a:pPr>
+            <a:r>
+              <a:rPr sz="1250" b="1">
+                <a:solidFill>
+                  <a:srgbClr val="222A35"/>
+                </a:solidFill>
+                <a:latin typeface="Calibri"/>
+              </a:rPr>
+              <a:t>Identified steady-state gains (per % choke):</a:t>
+            </a:r>
+          </a:p>
+          <a:p>
+            <a:pPr lvl="1">
+              <a:spcAft>
+                <a:spcPts val="500"/>
+              </a:spcAft>
+            </a:pPr>
+            <a:r>
+              <a:rPr sz="1250" b="0">
                 <a:solidFill>
                   <a:srgbClr val="555F6B"/>
                 </a:solidFill>
@@ -6299,7 +6331,7 @@
         </p:blipFill>
         <p:spPr>
           <a:xfrm>
-            <a:off x="5806440" y="1965960"/>
+            <a:off x="5806440" y="1920240"/>
             <a:ext cx="6035040" cy="3840480"/>
           </a:xfrm>
           <a:prstGeom prst="rect">

</xml_diff>